<commit_message>
Templates: NTOG logo on its transparent background (drop the white chip)
The NTOG logo always sits on transparency — remove the white chip behind it on
both the oral deck and the A1 poster.

Co-Authored-By: Claude Opus 4.8 <noreply@anthropic.com>
</commit_message>
<xml_diff>
--- a/ntog2027/nlcs2027-oral-template.pptx
+++ b/ntog2027/nlcs2027-oral-template.pptx
@@ -1505,36 +1505,9 @@
           <a:chExt cx="0" cy="0"/>
         </a:xfrm>
       </p:grpSpPr>
-      <p:sp>
-        <p:nvSpPr>
-          <p:cNvPr id="2" name="Shape 0"/>
-          <p:cNvSpPr/>
-          <p:nvPr/>
-        </p:nvSpPr>
-        <p:spPr>
-          <a:xfrm>
-            <a:off x="548640" y="457200"/>
-            <a:ext cx="960120" cy="960120"/>
-          </a:xfrm>
-          <a:prstGeom prst="roundRect">
-            <a:avLst>
-              <a:gd name="adj" fmla="val 7619"/>
-            </a:avLst>
-          </a:prstGeom>
-          <a:solidFill>
-            <a:srgbClr val="FFFFFF"/>
-          </a:solidFill>
-          <a:ln w="12700">
-            <a:solidFill>
-              <a:srgbClr val="F2B8C2"/>
-            </a:solidFill>
-            <a:prstDash val="solid"/>
-          </a:ln>
-        </p:spPr>
-      </p:sp>
       <p:pic>
         <p:nvPicPr>
-          <p:cNvPr id="3" name="Image 0" descr="/Users/heidiandersen/ntog/ntog-logo-1024.png">    </p:cNvPr>
+          <p:cNvPr id="2" name="Image 0" descr="/Users/heidiandersen/ntog/ntog-logo-1024.png">    </p:cNvPr>
           <p:cNvPicPr>
             <a:picLocks noChangeAspect="1"/>
           </p:cNvPicPr>
@@ -1548,8 +1521,8 @@
         </p:blipFill>
         <p:spPr>
           <a:xfrm>
-            <a:off x="692658" y="601218"/>
-            <a:ext cx="672084" cy="672084"/>
+            <a:off x="548640" y="457200"/>
+            <a:ext cx="960120" cy="960120"/>
           </a:xfrm>
           <a:prstGeom prst="rect">
             <a:avLst/>
@@ -1558,7 +1531,7 @@
       </p:pic>
       <p:sp>
         <p:nvSpPr>
-          <p:cNvPr id="4" name="Text 1"/>
+          <p:cNvPr id="3" name="Text 0"/>
           <p:cNvSpPr/>
           <p:nvPr/>
         </p:nvSpPr>
@@ -1597,7 +1570,7 @@
       </p:sp>
       <p:sp>
         <p:nvSpPr>
-          <p:cNvPr id="5" name="Text 2"/>
+          <p:cNvPr id="4" name="Text 1"/>
           <p:cNvSpPr/>
           <p:nvPr/>
         </p:nvSpPr>
@@ -1636,7 +1609,7 @@
       </p:sp>
       <p:sp>
         <p:nvSpPr>
-          <p:cNvPr id="6" name="Text 3"/>
+          <p:cNvPr id="5" name="Text 2"/>
           <p:cNvSpPr/>
           <p:nvPr/>
         </p:nvSpPr>
@@ -1675,7 +1648,7 @@
       </p:sp>
       <p:sp>
         <p:nvSpPr>
-          <p:cNvPr id="7" name="Text 4"/>
+          <p:cNvPr id="6" name="Text 3"/>
           <p:cNvSpPr/>
           <p:nvPr/>
         </p:nvSpPr>
@@ -1714,7 +1687,7 @@
       </p:sp>
       <p:sp>
         <p:nvSpPr>
-          <p:cNvPr id="8" name="Text 5"/>
+          <p:cNvPr id="7" name="Text 4"/>
           <p:cNvSpPr/>
           <p:nvPr/>
         </p:nvSpPr>
@@ -1913,36 +1886,9 @@
           </a:p>
         </p:txBody>
       </p:sp>
-      <p:sp>
-        <p:nvSpPr>
-          <p:cNvPr id="5" name="Shape 3"/>
-          <p:cNvSpPr/>
-          <p:nvPr/>
-        </p:nvSpPr>
-        <p:spPr>
-          <a:xfrm>
-            <a:off x="548640" y="6263640"/>
-            <a:ext cx="384048" cy="384048"/>
-          </a:xfrm>
-          <a:prstGeom prst="roundRect">
-            <a:avLst>
-              <a:gd name="adj" fmla="val 19048"/>
-            </a:avLst>
-          </a:prstGeom>
-          <a:solidFill>
-            <a:srgbClr val="FFFFFF"/>
-          </a:solidFill>
-          <a:ln w="12700">
-            <a:solidFill>
-              <a:srgbClr val="F2B8C2"/>
-            </a:solidFill>
-            <a:prstDash val="solid"/>
-          </a:ln>
-        </p:spPr>
-      </p:sp>
       <p:pic>
         <p:nvPicPr>
-          <p:cNvPr id="6" name="Image 0" descr="/Users/heidiandersen/ntog/ntog-logo-1024.png">    </p:cNvPr>
+          <p:cNvPr id="5" name="Image 0" descr="/Users/heidiandersen/ntog/ntog-logo-1024.png">    </p:cNvPr>
           <p:cNvPicPr>
             <a:picLocks noChangeAspect="1"/>
           </p:cNvPicPr>
@@ -1956,8 +1902,8 @@
         </p:blipFill>
         <p:spPr>
           <a:xfrm>
-            <a:off x="606247" y="6321247"/>
-            <a:ext cx="268834" cy="268834"/>
+            <a:off x="548640" y="6263640"/>
+            <a:ext cx="384048" cy="384048"/>
           </a:xfrm>
           <a:prstGeom prst="rect">
             <a:avLst/>
@@ -1966,7 +1912,7 @@
       </p:pic>
       <p:sp>
         <p:nvSpPr>
-          <p:cNvPr id="7" name="Text 4"/>
+          <p:cNvPr id="6" name="Text 3"/>
           <p:cNvSpPr/>
           <p:nvPr/>
         </p:nvSpPr>
@@ -2005,7 +1951,7 @@
       </p:sp>
       <p:sp>
         <p:nvSpPr>
-          <p:cNvPr id="8" name="Text 5"/>
+          <p:cNvPr id="7" name="Text 4"/>
           <p:cNvSpPr/>
           <p:nvPr/>
         </p:nvSpPr>
@@ -2237,36 +2183,9 @@
           </a:p>
         </p:txBody>
       </p:sp>
-      <p:sp>
-        <p:nvSpPr>
-          <p:cNvPr id="5" name="Shape 3"/>
-          <p:cNvSpPr/>
-          <p:nvPr/>
-        </p:nvSpPr>
-        <p:spPr>
-          <a:xfrm>
-            <a:off x="548640" y="6263640"/>
-            <a:ext cx="384048" cy="384048"/>
-          </a:xfrm>
-          <a:prstGeom prst="roundRect">
-            <a:avLst>
-              <a:gd name="adj" fmla="val 19048"/>
-            </a:avLst>
-          </a:prstGeom>
-          <a:solidFill>
-            <a:srgbClr val="FFFFFF"/>
-          </a:solidFill>
-          <a:ln w="12700">
-            <a:solidFill>
-              <a:srgbClr val="F2B8C2"/>
-            </a:solidFill>
-            <a:prstDash val="solid"/>
-          </a:ln>
-        </p:spPr>
-      </p:sp>
       <p:pic>
         <p:nvPicPr>
-          <p:cNvPr id="6" name="Image 0" descr="/Users/heidiandersen/ntog/ntog-logo-1024.png">    </p:cNvPr>
+          <p:cNvPr id="5" name="Image 0" descr="/Users/heidiandersen/ntog/ntog-logo-1024.png">    </p:cNvPr>
           <p:cNvPicPr>
             <a:picLocks noChangeAspect="1"/>
           </p:cNvPicPr>
@@ -2280,8 +2199,8 @@
         </p:blipFill>
         <p:spPr>
           <a:xfrm>
-            <a:off x="606247" y="6321247"/>
-            <a:ext cx="268834" cy="268834"/>
+            <a:off x="548640" y="6263640"/>
+            <a:ext cx="384048" cy="384048"/>
           </a:xfrm>
           <a:prstGeom prst="rect">
             <a:avLst/>
@@ -2290,7 +2209,7 @@
       </p:pic>
       <p:sp>
         <p:nvSpPr>
-          <p:cNvPr id="7" name="Text 4"/>
+          <p:cNvPr id="6" name="Text 3"/>
           <p:cNvSpPr/>
           <p:nvPr/>
         </p:nvSpPr>
@@ -2329,7 +2248,7 @@
       </p:sp>
       <p:sp>
         <p:nvSpPr>
-          <p:cNvPr id="8" name="Text 5"/>
+          <p:cNvPr id="7" name="Text 4"/>
           <p:cNvSpPr/>
           <p:nvPr/>
         </p:nvSpPr>
@@ -2506,36 +2425,9 @@
           </a:p>
         </p:txBody>
       </p:sp>
-      <p:sp>
-        <p:nvSpPr>
-          <p:cNvPr id="5" name="Shape 3"/>
-          <p:cNvSpPr/>
-          <p:nvPr/>
-        </p:nvSpPr>
-        <p:spPr>
-          <a:xfrm>
-            <a:off x="548640" y="6263640"/>
-            <a:ext cx="384048" cy="384048"/>
-          </a:xfrm>
-          <a:prstGeom prst="roundRect">
-            <a:avLst>
-              <a:gd name="adj" fmla="val 19048"/>
-            </a:avLst>
-          </a:prstGeom>
-          <a:solidFill>
-            <a:srgbClr val="FFFFFF"/>
-          </a:solidFill>
-          <a:ln w="12700">
-            <a:solidFill>
-              <a:srgbClr val="F2B8C2"/>
-            </a:solidFill>
-            <a:prstDash val="solid"/>
-          </a:ln>
-        </p:spPr>
-      </p:sp>
       <p:pic>
         <p:nvPicPr>
-          <p:cNvPr id="6" name="Image 0" descr="/Users/heidiandersen/ntog/ntog-logo-1024.png">    </p:cNvPr>
+          <p:cNvPr id="5" name="Image 0" descr="/Users/heidiandersen/ntog/ntog-logo-1024.png">    </p:cNvPr>
           <p:cNvPicPr>
             <a:picLocks noChangeAspect="1"/>
           </p:cNvPicPr>
@@ -2549,8 +2441,8 @@
         </p:blipFill>
         <p:spPr>
           <a:xfrm>
-            <a:off x="606247" y="6321247"/>
-            <a:ext cx="268834" cy="268834"/>
+            <a:off x="548640" y="6263640"/>
+            <a:ext cx="384048" cy="384048"/>
           </a:xfrm>
           <a:prstGeom prst="rect">
             <a:avLst/>
@@ -2559,7 +2451,7 @@
       </p:pic>
       <p:sp>
         <p:nvSpPr>
-          <p:cNvPr id="7" name="Text 4"/>
+          <p:cNvPr id="6" name="Text 3"/>
           <p:cNvSpPr/>
           <p:nvPr/>
         </p:nvSpPr>
@@ -2598,7 +2490,7 @@
       </p:sp>
       <p:sp>
         <p:nvSpPr>
-          <p:cNvPr id="8" name="Text 5"/>
+          <p:cNvPr id="7" name="Text 4"/>
           <p:cNvSpPr/>
           <p:nvPr/>
         </p:nvSpPr>
@@ -2791,36 +2683,9 @@
           </a:p>
         </p:txBody>
       </p:sp>
-      <p:sp>
-        <p:nvSpPr>
-          <p:cNvPr id="4" name="Shape 2"/>
-          <p:cNvSpPr/>
-          <p:nvPr/>
-        </p:nvSpPr>
-        <p:spPr>
-          <a:xfrm>
-            <a:off x="548640" y="6263640"/>
-            <a:ext cx="384048" cy="384048"/>
-          </a:xfrm>
-          <a:prstGeom prst="roundRect">
-            <a:avLst>
-              <a:gd name="adj" fmla="val 19048"/>
-            </a:avLst>
-          </a:prstGeom>
-          <a:solidFill>
-            <a:srgbClr val="FFFFFF"/>
-          </a:solidFill>
-          <a:ln w="12700">
-            <a:solidFill>
-              <a:srgbClr val="F2B8C2"/>
-            </a:solidFill>
-            <a:prstDash val="solid"/>
-          </a:ln>
-        </p:spPr>
-      </p:sp>
       <p:pic>
         <p:nvPicPr>
-          <p:cNvPr id="5" name="Image 0" descr="/Users/heidiandersen/ntog/ntog-logo-1024.png">    </p:cNvPr>
+          <p:cNvPr id="4" name="Image 0" descr="/Users/heidiandersen/ntog/ntog-logo-1024.png">    </p:cNvPr>
           <p:cNvPicPr>
             <a:picLocks noChangeAspect="1"/>
           </p:cNvPicPr>
@@ -2834,8 +2699,8 @@
         </p:blipFill>
         <p:spPr>
           <a:xfrm>
-            <a:off x="606247" y="6321247"/>
-            <a:ext cx="268834" cy="268834"/>
+            <a:off x="548640" y="6263640"/>
+            <a:ext cx="384048" cy="384048"/>
           </a:xfrm>
           <a:prstGeom prst="rect">
             <a:avLst/>
@@ -2844,7 +2709,7 @@
       </p:pic>
       <p:sp>
         <p:nvSpPr>
-          <p:cNvPr id="6" name="Text 3"/>
+          <p:cNvPr id="5" name="Text 2"/>
           <p:cNvSpPr/>
           <p:nvPr/>
         </p:nvSpPr>
@@ -2883,7 +2748,7 @@
       </p:sp>
       <p:sp>
         <p:nvSpPr>
-          <p:cNvPr id="7" name="Text 4"/>
+          <p:cNvPr id="6" name="Text 3"/>
           <p:cNvSpPr/>
           <p:nvPr/>
         </p:nvSpPr>
@@ -3177,36 +3042,9 @@
           </a:p>
         </p:txBody>
       </p:sp>
-      <p:sp>
-        <p:nvSpPr>
-          <p:cNvPr id="8" name="Shape 6"/>
-          <p:cNvSpPr/>
-          <p:nvPr/>
-        </p:nvSpPr>
-        <p:spPr>
-          <a:xfrm>
-            <a:off x="548640" y="6263640"/>
-            <a:ext cx="384048" cy="384048"/>
-          </a:xfrm>
-          <a:prstGeom prst="roundRect">
-            <a:avLst>
-              <a:gd name="adj" fmla="val 19048"/>
-            </a:avLst>
-          </a:prstGeom>
-          <a:solidFill>
-            <a:srgbClr val="FFFFFF"/>
-          </a:solidFill>
-          <a:ln w="12700">
-            <a:solidFill>
-              <a:srgbClr val="F2B8C2"/>
-            </a:solidFill>
-            <a:prstDash val="solid"/>
-          </a:ln>
-        </p:spPr>
-      </p:sp>
       <p:pic>
         <p:nvPicPr>
-          <p:cNvPr id="9" name="Image 0" descr="/Users/heidiandersen/ntog/ntog-logo-1024.png">    </p:cNvPr>
+          <p:cNvPr id="8" name="Image 0" descr="/Users/heidiandersen/ntog/ntog-logo-1024.png">    </p:cNvPr>
           <p:cNvPicPr>
             <a:picLocks noChangeAspect="1"/>
           </p:cNvPicPr>
@@ -3220,8 +3058,8 @@
         </p:blipFill>
         <p:spPr>
           <a:xfrm>
-            <a:off x="606247" y="6321247"/>
-            <a:ext cx="268834" cy="268834"/>
+            <a:off x="548640" y="6263640"/>
+            <a:ext cx="384048" cy="384048"/>
           </a:xfrm>
           <a:prstGeom prst="rect">
             <a:avLst/>
@@ -3230,7 +3068,7 @@
       </p:pic>
       <p:sp>
         <p:nvSpPr>
-          <p:cNvPr id="10" name="Text 7"/>
+          <p:cNvPr id="9" name="Text 6"/>
           <p:cNvSpPr/>
           <p:nvPr/>
         </p:nvSpPr>
@@ -3269,7 +3107,7 @@
       </p:sp>
       <p:sp>
         <p:nvSpPr>
-          <p:cNvPr id="11" name="Text 8"/>
+          <p:cNvPr id="10" name="Text 7"/>
           <p:cNvSpPr/>
           <p:nvPr/>
         </p:nvSpPr>
@@ -3586,36 +3424,9 @@
           </a:p>
         </p:txBody>
       </p:sp>
-      <p:sp>
-        <p:nvSpPr>
-          <p:cNvPr id="4" name="Shape 2"/>
-          <p:cNvSpPr/>
-          <p:nvPr/>
-        </p:nvSpPr>
-        <p:spPr>
-          <a:xfrm>
-            <a:off x="548640" y="5120640"/>
-            <a:ext cx="914400" cy="914400"/>
-          </a:xfrm>
-          <a:prstGeom prst="roundRect">
-            <a:avLst>
-              <a:gd name="adj" fmla="val 8000"/>
-            </a:avLst>
-          </a:prstGeom>
-          <a:solidFill>
-            <a:srgbClr val="FFFFFF"/>
-          </a:solidFill>
-          <a:ln w="12700">
-            <a:solidFill>
-              <a:srgbClr val="F2B8C2"/>
-            </a:solidFill>
-            <a:prstDash val="solid"/>
-          </a:ln>
-        </p:spPr>
-      </p:sp>
       <p:pic>
         <p:nvPicPr>
-          <p:cNvPr id="5" name="Image 0" descr="/Users/heidiandersen/ntog/ntog-logo-1024.png">    </p:cNvPr>
+          <p:cNvPr id="4" name="Image 0" descr="/Users/heidiandersen/ntog/ntog-logo-1024.png">    </p:cNvPr>
           <p:cNvPicPr>
             <a:picLocks noChangeAspect="1"/>
           </p:cNvPicPr>
@@ -3629,8 +3440,8 @@
         </p:blipFill>
         <p:spPr>
           <a:xfrm>
-            <a:off x="685800" y="5257800"/>
-            <a:ext cx="640080" cy="640080"/>
+            <a:off x="548640" y="5120640"/>
+            <a:ext cx="914400" cy="914400"/>
           </a:xfrm>
           <a:prstGeom prst="rect">
             <a:avLst/>
@@ -3639,7 +3450,7 @@
       </p:pic>
       <p:sp>
         <p:nvSpPr>
-          <p:cNvPr id="6" name="Text 3"/>
+          <p:cNvPr id="5" name="Text 2"/>
           <p:cNvSpPr/>
           <p:nvPr/>
         </p:nvSpPr>
@@ -3678,7 +3489,7 @@
       </p:sp>
       <p:sp>
         <p:nvSpPr>
-          <p:cNvPr id="7" name="Text 4"/>
+          <p:cNvPr id="6" name="Text 3"/>
           <p:cNvSpPr/>
           <p:nvPr/>
         </p:nvSpPr>

</xml_diff>